<commit_message>
Add architecture diagram and update documentation
- Add architecture-diagram.png (visual system diagram)
- Add architecture.html (interactive HTML version with styling)
- Rename ARCHITECTURE_DIAGRAM.md to Architecture.md
- Update Architecture.md to display diagram image
- Update README.md with architecture diagram and improved documentation section
- Update B2B_Sales_Agent_Progress_Report.pptx
</commit_message>
<xml_diff>
--- a/B2B_Sales_Agent_Progress_Report.pptx
+++ b/B2B_Sales_Agent_Progress_Report.pptx
@@ -5,26 +5,27 @@
     <p:sldMasterId id="2147483648" r:id="rId1"/>
   </p:sldMasterIdLst>
   <p:notesMasterIdLst>
-    <p:notesMasterId r:id="rId19"/>
+    <p:notesMasterId r:id="rId20"/>
   </p:notesMasterIdLst>
   <p:sldIdLst>
     <p:sldId id="256" r:id="rId2"/>
     <p:sldId id="257" r:id="rId3"/>
     <p:sldId id="258" r:id="rId4"/>
     <p:sldId id="259" r:id="rId5"/>
-    <p:sldId id="271" r:id="rId6"/>
-    <p:sldId id="260" r:id="rId7"/>
-    <p:sldId id="261" r:id="rId8"/>
-    <p:sldId id="262" r:id="rId9"/>
-    <p:sldId id="263" r:id="rId10"/>
-    <p:sldId id="264" r:id="rId11"/>
-    <p:sldId id="265" r:id="rId12"/>
-    <p:sldId id="266" r:id="rId13"/>
-    <p:sldId id="267" r:id="rId14"/>
-    <p:sldId id="268" r:id="rId15"/>
-    <p:sldId id="269" r:id="rId16"/>
-    <p:sldId id="270" r:id="rId17"/>
-    <p:sldId id="272" r:id="rId18"/>
+    <p:sldId id="274" r:id="rId6"/>
+    <p:sldId id="271" r:id="rId7"/>
+    <p:sldId id="260" r:id="rId8"/>
+    <p:sldId id="261" r:id="rId9"/>
+    <p:sldId id="262" r:id="rId10"/>
+    <p:sldId id="263" r:id="rId11"/>
+    <p:sldId id="264" r:id="rId12"/>
+    <p:sldId id="265" r:id="rId13"/>
+    <p:sldId id="266" r:id="rId14"/>
+    <p:sldId id="267" r:id="rId15"/>
+    <p:sldId id="268" r:id="rId16"/>
+    <p:sldId id="269" r:id="rId17"/>
+    <p:sldId id="270" r:id="rId18"/>
+    <p:sldId id="272" r:id="rId19"/>
   </p:sldIdLst>
   <p:sldSz cx="9144000" cy="5143500" type="screen16x9"/>
   <p:notesSz cx="5143500" cy="9144000"/>
@@ -1009,6 +1010,90 @@
 </p:notes>
 </file>
 
+<file path=ppt/notesSlides/notesSlide18.xml><?xml version="1.0" encoding="utf-8"?>
+<p:notes xmlns:a="http://schemas.openxmlformats.org/drawingml/2006/main" xmlns:r="http://schemas.openxmlformats.org/officeDocument/2006/relationships" xmlns:p="http://schemas.openxmlformats.org/presentationml/2006/main">
+  <p:cSld>
+    <p:spTree>
+      <p:nvGrpSpPr>
+        <p:cNvPr id="1" name=""/>
+        <p:cNvGrpSpPr/>
+        <p:nvPr/>
+      </p:nvGrpSpPr>
+      <p:grpSpPr>
+        <a:xfrm>
+          <a:off x="0" y="0"/>
+          <a:ext cx="0" cy="0"/>
+          <a:chOff x="0" y="0"/>
+          <a:chExt cx="0" cy="0"/>
+        </a:xfrm>
+      </p:grpSpPr>
+      <p:sp>
+        <p:nvSpPr>
+          <p:cNvPr id="2" name="Slide Image Placeholder 1"/>
+          <p:cNvSpPr>
+            <a:spLocks noGrp="1" noRot="1" noChangeAspect="1"/>
+          </p:cNvSpPr>
+          <p:nvPr>
+            <p:ph type="sldImg"/>
+          </p:nvPr>
+        </p:nvSpPr>
+        <p:spPr/>
+      </p:sp>
+      <p:sp>
+        <p:nvSpPr>
+          <p:cNvPr id="3" name="Notes Placeholder 2"/>
+          <p:cNvSpPr>
+            <a:spLocks noGrp="1"/>
+          </p:cNvSpPr>
+          <p:nvPr>
+            <p:ph type="body" idx="1"/>
+          </p:nvPr>
+        </p:nvSpPr>
+        <p:spPr/>
+        <p:txBody>
+          <a:bodyPr/>
+          <a:lstStyle/>
+          <a:p>
+            <a:endParaRPr lang="en-US" dirty="0"/>
+          </a:p>
+        </p:txBody>
+      </p:sp>
+      <p:sp>
+        <p:nvSpPr>
+          <p:cNvPr id="4" name="Slide Number Placeholder 3"/>
+          <p:cNvSpPr>
+            <a:spLocks noGrp="1"/>
+          </p:cNvSpPr>
+          <p:nvPr>
+            <p:ph type="sldNum" sz="quarter" idx="10"/>
+          </p:nvPr>
+        </p:nvSpPr>
+        <p:spPr/>
+        <p:txBody>
+          <a:bodyPr/>
+          <a:lstStyle/>
+          <a:p>
+            <a:fld id="{F7021451-1387-4CA6-816F-3879F97B5CBC}" type="slidenum">
+              <a:rPr lang="en-US"/>
+              <a:t>18</a:t>
+            </a:fld>
+            <a:endParaRPr lang="en-US"/>
+          </a:p>
+        </p:txBody>
+      </p:sp>
+    </p:spTree>
+    <p:extLst>
+      <p:ext uri="{BB962C8B-B14F-4D97-AF65-F5344CB8AC3E}">
+        <p14:creationId xmlns:p14="http://schemas.microsoft.com/office/powerpoint/2010/main" val="1024086991"/>
+      </p:ext>
+    </p:extLst>
+  </p:cSld>
+  <p:clrMapOvr>
+    <a:masterClrMapping/>
+  </p:clrMapOvr>
+</p:notes>
+</file>
+
 <file path=ppt/notesSlides/notesSlide2.xml><?xml version="1.0" encoding="utf-8"?>
 <p:notes xmlns:a="http://schemas.openxmlformats.org/drawingml/2006/main" xmlns:r="http://schemas.openxmlformats.org/officeDocument/2006/relationships" xmlns:p="http://schemas.openxmlformats.org/presentationml/2006/main">
   <p:cSld>
@@ -1266,7 +1351,13 @@
   <p:cSld>
     <p:spTree>
       <p:nvGrpSpPr>
-        <p:cNvPr id="1" name=""/>
+        <p:cNvPr id="1" name="">
+          <a:extLst>
+            <a:ext uri="{FF2B5EF4-FFF2-40B4-BE49-F238E27FC236}">
+              <a16:creationId xmlns:a16="http://schemas.microsoft.com/office/drawing/2014/main" id="{DFA8788F-D364-E037-2FEE-4A17B586B6CA}"/>
+            </a:ext>
+          </a:extLst>
+        </p:cNvPr>
         <p:cNvGrpSpPr/>
         <p:nvPr/>
       </p:nvGrpSpPr>
@@ -1280,7 +1371,13 @@
       </p:grpSpPr>
       <p:sp>
         <p:nvSpPr>
-          <p:cNvPr id="2" name="Slide Image Placeholder 1"/>
+          <p:cNvPr id="2" name="Slide Image Placeholder 1">
+            <a:extLst>
+              <a:ext uri="{FF2B5EF4-FFF2-40B4-BE49-F238E27FC236}">
+                <a16:creationId xmlns:a16="http://schemas.microsoft.com/office/drawing/2014/main" id="{ADC08A34-04D9-D846-BEAE-2E42B738EA87}"/>
+              </a:ext>
+            </a:extLst>
+          </p:cNvPr>
           <p:cNvSpPr>
             <a:spLocks noGrp="1" noRot="1" noChangeAspect="1"/>
           </p:cNvSpPr>
@@ -1292,7 +1389,13 @@
       </p:sp>
       <p:sp>
         <p:nvSpPr>
-          <p:cNvPr id="3" name="Notes Placeholder 2"/>
+          <p:cNvPr id="3" name="Notes Placeholder 2">
+            <a:extLst>
+              <a:ext uri="{FF2B5EF4-FFF2-40B4-BE49-F238E27FC236}">
+                <a16:creationId xmlns:a16="http://schemas.microsoft.com/office/drawing/2014/main" id="{6C57E743-CA1E-4FA4-1DB3-4D4CB042C2BF}"/>
+              </a:ext>
+            </a:extLst>
+          </p:cNvPr>
           <p:cNvSpPr>
             <a:spLocks noGrp="1"/>
           </p:cNvSpPr>
@@ -1311,7 +1414,13 @@
       </p:sp>
       <p:sp>
         <p:nvSpPr>
-          <p:cNvPr id="4" name="Slide Number Placeholder 3"/>
+          <p:cNvPr id="4" name="Slide Number Placeholder 3">
+            <a:extLst>
+              <a:ext uri="{FF2B5EF4-FFF2-40B4-BE49-F238E27FC236}">
+                <a16:creationId xmlns:a16="http://schemas.microsoft.com/office/drawing/2014/main" id="{1F744D90-946E-E795-C21E-10994564CBE6}"/>
+              </a:ext>
+            </a:extLst>
+          </p:cNvPr>
           <p:cNvSpPr>
             <a:spLocks noGrp="1"/>
           </p:cNvSpPr>
@@ -1335,7 +1444,7 @@
     </p:spTree>
     <p:extLst>
       <p:ext uri="{BB962C8B-B14F-4D97-AF65-F5344CB8AC3E}">
-        <p14:creationId xmlns:p14="http://schemas.microsoft.com/office/powerpoint/2010/main" val="1024086991"/>
+        <p14:creationId xmlns:p14="http://schemas.microsoft.com/office/powerpoint/2010/main" val="15303609"/>
       </p:ext>
     </p:extLst>
   </p:cSld>
@@ -2350,6 +2459,692 @@
 </file>
 
 <file path=ppt/slides/slide10.xml><?xml version="1.0" encoding="utf-8"?>
+<p:sld xmlns:a="http://schemas.openxmlformats.org/drawingml/2006/main" xmlns:r="http://schemas.openxmlformats.org/officeDocument/2006/relationships" xmlns:p="http://schemas.openxmlformats.org/presentationml/2006/main">
+  <p:cSld name="Slide 8">
+    <p:bg>
+      <p:bgPr>
+        <a:solidFill>
+          <a:srgbClr val="0B1120"/>
+        </a:solidFill>
+        <a:effectLst/>
+      </p:bgPr>
+    </p:bg>
+    <p:spTree>
+      <p:nvGrpSpPr>
+        <p:cNvPr id="1" name=""/>
+        <p:cNvGrpSpPr/>
+        <p:nvPr/>
+      </p:nvGrpSpPr>
+      <p:grpSpPr>
+        <a:xfrm>
+          <a:off x="0" y="0"/>
+          <a:ext cx="0" cy="0"/>
+          <a:chOff x="0" y="0"/>
+          <a:chExt cx="0" cy="0"/>
+        </a:xfrm>
+      </p:grpSpPr>
+      <p:sp>
+        <p:nvSpPr>
+          <p:cNvPr id="2" name="Text 0"/>
+          <p:cNvSpPr/>
+          <p:nvPr/>
+        </p:nvSpPr>
+        <p:spPr>
+          <a:xfrm>
+            <a:off x="640080" y="274320"/>
+            <a:ext cx="7863840" cy="502920"/>
+          </a:xfrm>
+          <a:prstGeom prst="rect">
+            <a:avLst/>
+          </a:prstGeom>
+          <a:noFill/>
+          <a:ln/>
+        </p:spPr>
+        <p:txBody>
+          <a:bodyPr wrap="square" lIns="0" tIns="0" rIns="0" bIns="0" rtlCol="0" anchor="ctr"/>
+          <a:lstStyle/>
+          <a:p>
+            <a:pPr marL="0" indent="0">
+              <a:buNone/>
+            </a:pPr>
+            <a:r>
+              <a:rPr lang="en-US" sz="2800" b="1" dirty="0">
+                <a:solidFill>
+                  <a:srgbClr val="E2E8F0"/>
+                </a:solidFill>
+                <a:latin typeface="Trebuchet MS" pitchFamily="34" charset="0"/>
+                <a:ea typeface="Trebuchet MS" pitchFamily="34" charset="-122"/>
+                <a:cs typeface="Trebuchet MS" pitchFamily="34" charset="-120"/>
+              </a:rPr>
+              <a:t>Code: Sub-Agent — Deterministic Agent Pattern</a:t>
+            </a:r>
+            <a:endParaRPr lang="en-US" sz="2800" dirty="0"/>
+          </a:p>
+        </p:txBody>
+      </p:sp>
+      <p:sp>
+        <p:nvSpPr>
+          <p:cNvPr id="3" name="Text 1"/>
+          <p:cNvSpPr/>
+          <p:nvPr/>
+        </p:nvSpPr>
+        <p:spPr>
+          <a:xfrm>
+            <a:off x="7772400" y="4754880"/>
+            <a:ext cx="1097280" cy="274320"/>
+          </a:xfrm>
+          <a:prstGeom prst="rect">
+            <a:avLst/>
+          </a:prstGeom>
+          <a:noFill/>
+          <a:ln/>
+        </p:spPr>
+        <p:txBody>
+          <a:bodyPr wrap="square" rtlCol="0" anchor="ctr"/>
+          <a:lstStyle/>
+          <a:p>
+            <a:pPr marL="0" indent="0" algn="r">
+              <a:buNone/>
+            </a:pPr>
+            <a:r>
+              <a:rPr lang="en-US" sz="900" dirty="0">
+                <a:solidFill>
+                  <a:srgbClr val="94A3B8"/>
+                </a:solidFill>
+                <a:latin typeface="Calibri" pitchFamily="34" charset="0"/>
+                <a:ea typeface="Calibri" pitchFamily="34" charset="-122"/>
+                <a:cs typeface="Calibri" pitchFamily="34" charset="-120"/>
+              </a:rPr>
+              <a:t>8 / 17</a:t>
+            </a:r>
+            <a:endParaRPr lang="en-US" sz="900" dirty="0"/>
+          </a:p>
+        </p:txBody>
+      </p:sp>
+      <p:sp>
+        <p:nvSpPr>
+          <p:cNvPr id="4" name="Text 2"/>
+          <p:cNvSpPr/>
+          <p:nvPr/>
+        </p:nvSpPr>
+        <p:spPr>
+          <a:xfrm>
+            <a:off x="640080" y="777240"/>
+            <a:ext cx="7863840" cy="320040"/>
+          </a:xfrm>
+          <a:prstGeom prst="rect">
+            <a:avLst/>
+          </a:prstGeom>
+          <a:noFill/>
+          <a:ln/>
+        </p:spPr>
+        <p:txBody>
+          <a:bodyPr wrap="square" lIns="0" tIns="0" rIns="0" bIns="0" rtlCol="0" anchor="ctr"/>
+          <a:lstStyle/>
+          <a:p>
+            <a:pPr marL="0" indent="0">
+              <a:buNone/>
+            </a:pPr>
+            <a:r>
+              <a:rPr lang="en-US" sz="1100" i="1" dirty="0">
+                <a:solidFill>
+                  <a:srgbClr val="94A3B8"/>
+                </a:solidFill>
+                <a:latin typeface="Calibri" pitchFamily="34" charset="0"/>
+                <a:ea typeface="Calibri" pitchFamily="34" charset="-122"/>
+                <a:cs typeface="Calibri" pitchFamily="34" charset="-120"/>
+              </a:rPr>
+              <a:t>Sub-agents like ServiceabilityAgent use temperature 0.0 for deterministic, tool-based responses.</a:t>
+            </a:r>
+            <a:endParaRPr lang="en-US" sz="1100" dirty="0"/>
+          </a:p>
+        </p:txBody>
+      </p:sp>
+      <p:sp>
+        <p:nvSpPr>
+          <p:cNvPr id="5" name="Shape 3"/>
+          <p:cNvSpPr/>
+          <p:nvPr/>
+        </p:nvSpPr>
+        <p:spPr>
+          <a:xfrm>
+            <a:off x="457200" y="1188720"/>
+            <a:ext cx="8229600" cy="3657600"/>
+          </a:xfrm>
+          <a:prstGeom prst="rect">
+            <a:avLst/>
+          </a:prstGeom>
+          <a:solidFill>
+            <a:srgbClr val="0F172A"/>
+          </a:solidFill>
+          <a:ln/>
+          <a:effectLst>
+            <a:outerShdw blurRad="76200" dist="25400" dir="8100000" algn="bl" rotWithShape="0">
+              <a:srgbClr val="000000">
+                <a:alpha val="12000"/>
+              </a:srgbClr>
+            </a:outerShdw>
+          </a:effectLst>
+        </p:spPr>
+        <p:txBody>
+          <a:bodyPr/>
+          <a:lstStyle/>
+          <a:p>
+            <a:endParaRPr lang="en-US"/>
+          </a:p>
+        </p:txBody>
+      </p:sp>
+      <p:sp>
+        <p:nvSpPr>
+          <p:cNvPr id="6" name="Text 4"/>
+          <p:cNvSpPr/>
+          <p:nvPr/>
+        </p:nvSpPr>
+        <p:spPr>
+          <a:xfrm>
+            <a:off x="594360" y="1280160"/>
+            <a:ext cx="7955280" cy="3474720"/>
+          </a:xfrm>
+          <a:prstGeom prst="rect">
+            <a:avLst/>
+          </a:prstGeom>
+          <a:noFill/>
+          <a:ln/>
+        </p:spPr>
+        <p:txBody>
+          <a:bodyPr wrap="square" rtlCol="0" anchor="t"/>
+          <a:lstStyle/>
+          <a:p>
+            <a:pPr marL="0" indent="0">
+              <a:lnSpc>
+                <a:spcPct val="115000"/>
+              </a:lnSpc>
+              <a:buNone/>
+            </a:pPr>
+            <a:r>
+              <a:rPr lang="en-US" sz="850" dirty="0">
+                <a:solidFill>
+                  <a:srgbClr val="C586C0"/>
+                </a:solidFill>
+                <a:latin typeface="Consolas" pitchFamily="34" charset="0"/>
+                <a:ea typeface="Consolas" pitchFamily="34" charset="-122"/>
+                <a:cs typeface="Consolas" pitchFamily="34" charset="-120"/>
+              </a:rPr>
+              <a:t>from google.adk.agents import Agent</a:t>
+            </a:r>
+            <a:endParaRPr lang="en-US" sz="850" dirty="0"/>
+          </a:p>
+          <a:p>
+            <a:pPr marL="0" indent="0">
+              <a:lnSpc>
+                <a:spcPct val="115000"/>
+              </a:lnSpc>
+              <a:buNone/>
+            </a:pPr>
+            <a:r>
+              <a:rPr lang="en-US" sz="850" dirty="0">
+                <a:solidFill>
+                  <a:srgbClr val="C586C0"/>
+                </a:solidFill>
+                <a:latin typeface="Consolas" pitchFamily="34" charset="0"/>
+                <a:ea typeface="Consolas" pitchFamily="34" charset="-122"/>
+                <a:cs typeface="Consolas" pitchFamily="34" charset="-120"/>
+              </a:rPr>
+              <a:t>from google.genai import types</a:t>
+            </a:r>
+            <a:endParaRPr lang="en-US" sz="850" dirty="0"/>
+          </a:p>
+          <a:p>
+            <a:pPr marL="0" indent="0">
+              <a:lnSpc>
+                <a:spcPct val="115000"/>
+              </a:lnSpc>
+              <a:buNone/>
+            </a:pPr>
+            <a:r>
+              <a:rPr lang="en-US" sz="850" dirty="0">
+                <a:solidFill>
+                  <a:srgbClr val="C586C0"/>
+                </a:solidFill>
+                <a:latin typeface="Consolas" pitchFamily="34" charset="0"/>
+                <a:ea typeface="Consolas" pitchFamily="34" charset="-122"/>
+                <a:cs typeface="Consolas" pitchFamily="34" charset="-120"/>
+              </a:rPr>
+              <a:t>from .tools.gis_tools import check_service_availability</a:t>
+            </a:r>
+            <a:endParaRPr lang="en-US" sz="850" dirty="0"/>
+          </a:p>
+          <a:p>
+            <a:pPr marL="0" indent="0">
+              <a:lnSpc>
+                <a:spcPct val="115000"/>
+              </a:lnSpc>
+              <a:buNone/>
+            </a:pPr>
+            <a:r>
+              <a:rPr lang="en-US" sz="850" dirty="0">
+                <a:solidFill>
+                  <a:srgbClr val="E2E8F0"/>
+                </a:solidFill>
+                <a:latin typeface="Consolas" pitchFamily="34" charset="0"/>
+                <a:ea typeface="Consolas" pitchFamily="34" charset="-122"/>
+                <a:cs typeface="Consolas" pitchFamily="34" charset="-120"/>
+              </a:rPr>
+              <a:t> </a:t>
+            </a:r>
+            <a:endParaRPr lang="en-US" sz="850" dirty="0"/>
+          </a:p>
+          <a:p>
+            <a:pPr marL="0" indent="0">
+              <a:lnSpc>
+                <a:spcPct val="115000"/>
+              </a:lnSpc>
+              <a:buNone/>
+            </a:pPr>
+            <a:r>
+              <a:rPr lang="en-US" sz="850" dirty="0">
+                <a:solidFill>
+                  <a:srgbClr val="6A9955"/>
+                </a:solidFill>
+                <a:latin typeface="Consolas" pitchFamily="34" charset="0"/>
+                <a:ea typeface="Consolas" pitchFamily="34" charset="-122"/>
+                <a:cs typeface="Consolas" pitchFamily="34" charset="-120"/>
+              </a:rPr>
+              <a:t># Hardcoded name — never read from .env to avoid conflicts</a:t>
+            </a:r>
+            <a:endParaRPr lang="en-US" sz="850" dirty="0"/>
+          </a:p>
+          <a:p>
+            <a:pPr marL="0" indent="0">
+              <a:lnSpc>
+                <a:spcPct val="115000"/>
+              </a:lnSpc>
+              <a:buNone/>
+            </a:pPr>
+            <a:r>
+              <a:rPr lang="en-US" sz="850" dirty="0">
+                <a:solidFill>
+                  <a:srgbClr val="CE9178"/>
+                </a:solidFill>
+                <a:latin typeface="Consolas" pitchFamily="34" charset="0"/>
+                <a:ea typeface="Consolas" pitchFamily="34" charset="-122"/>
+                <a:cs typeface="Consolas" pitchFamily="34" charset="-120"/>
+              </a:rPr>
+              <a:t>GEMINI_MODEL = os.getenv("GEMINI_MODEL")</a:t>
+            </a:r>
+            <a:endParaRPr lang="en-US" sz="850" dirty="0"/>
+          </a:p>
+          <a:p>
+            <a:pPr marL="0" indent="0">
+              <a:lnSpc>
+                <a:spcPct val="115000"/>
+              </a:lnSpc>
+              <a:buNone/>
+            </a:pPr>
+            <a:r>
+              <a:rPr lang="en-US" sz="850" dirty="0">
+                <a:solidFill>
+                  <a:srgbClr val="E2E8F0"/>
+                </a:solidFill>
+                <a:latin typeface="Consolas" pitchFamily="34" charset="0"/>
+                <a:ea typeface="Consolas" pitchFamily="34" charset="-122"/>
+                <a:cs typeface="Consolas" pitchFamily="34" charset="-120"/>
+              </a:rPr>
+              <a:t> </a:t>
+            </a:r>
+            <a:endParaRPr lang="en-US" sz="850" dirty="0"/>
+          </a:p>
+          <a:p>
+            <a:pPr marL="0" indent="0">
+              <a:lnSpc>
+                <a:spcPct val="115000"/>
+              </a:lnSpc>
+              <a:buNone/>
+            </a:pPr>
+            <a:r>
+              <a:rPr lang="en-US" sz="850" dirty="0">
+                <a:solidFill>
+                  <a:srgbClr val="E2E8F0"/>
+                </a:solidFill>
+                <a:latin typeface="Consolas" pitchFamily="34" charset="0"/>
+                <a:ea typeface="Consolas" pitchFamily="34" charset="-122"/>
+                <a:cs typeface="Consolas" pitchFamily="34" charset="-120"/>
+              </a:rPr>
+              <a:t>serviceability_agent = Agent(</a:t>
+            </a:r>
+            <a:endParaRPr lang="en-US" sz="850" dirty="0"/>
+          </a:p>
+          <a:p>
+            <a:pPr marL="0" indent="0">
+              <a:lnSpc>
+                <a:spcPct val="115000"/>
+              </a:lnSpc>
+              <a:buNone/>
+            </a:pPr>
+            <a:r>
+              <a:rPr lang="en-US" sz="850" dirty="0">
+                <a:solidFill>
+                  <a:srgbClr val="CE9178"/>
+                </a:solidFill>
+                <a:latin typeface="Consolas" pitchFamily="34" charset="0"/>
+                <a:ea typeface="Consolas" pitchFamily="34" charset="-122"/>
+                <a:cs typeface="Consolas" pitchFamily="34" charset="-120"/>
+              </a:rPr>
+              <a:t>    name="serviceability_agent",            # Hardcoded, not from env var</a:t>
+            </a:r>
+            <a:endParaRPr lang="en-US" sz="850" dirty="0"/>
+          </a:p>
+          <a:p>
+            <a:pPr marL="0" indent="0">
+              <a:lnSpc>
+                <a:spcPct val="115000"/>
+              </a:lnSpc>
+              <a:buNone/>
+            </a:pPr>
+            <a:r>
+              <a:rPr lang="en-US" sz="850" dirty="0">
+                <a:solidFill>
+                  <a:srgbClr val="E2E8F0"/>
+                </a:solidFill>
+                <a:latin typeface="Consolas" pitchFamily="34" charset="0"/>
+                <a:ea typeface="Consolas" pitchFamily="34" charset="-122"/>
+                <a:cs typeface="Consolas" pitchFamily="34" charset="-120"/>
+              </a:rPr>
+              <a:t>    model=GEMINI_MODEL,</a:t>
+            </a:r>
+            <a:endParaRPr lang="en-US" sz="850" dirty="0"/>
+          </a:p>
+          <a:p>
+            <a:pPr marL="0" indent="0">
+              <a:lnSpc>
+                <a:spcPct val="115000"/>
+              </a:lnSpc>
+              <a:buNone/>
+            </a:pPr>
+            <a:r>
+              <a:rPr lang="en-US" sz="850" dirty="0">
+                <a:solidFill>
+                  <a:srgbClr val="E2E8F0"/>
+                </a:solidFill>
+                <a:latin typeface="Consolas" pitchFamily="34" charset="0"/>
+                <a:ea typeface="Consolas" pitchFamily="34" charset="-122"/>
+                <a:cs typeface="Consolas" pitchFamily="34" charset="-120"/>
+              </a:rPr>
+              <a:t>    instruction=SERVICEABILITY_INSTRUCTION, # Domain-specific prompt</a:t>
+            </a:r>
+            <a:endParaRPr lang="en-US" sz="850" dirty="0"/>
+          </a:p>
+          <a:p>
+            <a:pPr marL="0" indent="0">
+              <a:lnSpc>
+                <a:spcPct val="115000"/>
+              </a:lnSpc>
+              <a:buNone/>
+            </a:pPr>
+            <a:r>
+              <a:rPr lang="en-US" sz="850" dirty="0">
+                <a:solidFill>
+                  <a:srgbClr val="CE9178"/>
+                </a:solidFill>
+                <a:latin typeface="Consolas" pitchFamily="34" charset="0"/>
+                <a:ea typeface="Consolas" pitchFamily="34" charset="-122"/>
+                <a:cs typeface="Consolas" pitchFamily="34" charset="-120"/>
+              </a:rPr>
+              <a:t>    description="PRE-SALE address validation &amp; coverage check",</a:t>
+            </a:r>
+            <a:endParaRPr lang="en-US" sz="850" dirty="0"/>
+          </a:p>
+          <a:p>
+            <a:pPr marL="0" indent="0">
+              <a:lnSpc>
+                <a:spcPct val="115000"/>
+              </a:lnSpc>
+              <a:buNone/>
+            </a:pPr>
+            <a:r>
+              <a:rPr lang="en-US" sz="850" dirty="0">
+                <a:solidFill>
+                  <a:srgbClr val="E2E8F0"/>
+                </a:solidFill>
+                <a:latin typeface="Consolas" pitchFamily="34" charset="0"/>
+                <a:ea typeface="Consolas" pitchFamily="34" charset="-122"/>
+                <a:cs typeface="Consolas" pitchFamily="34" charset="-120"/>
+              </a:rPr>
+              <a:t>    tools=[</a:t>
+            </a:r>
+            <a:endParaRPr lang="en-US" sz="850" dirty="0"/>
+          </a:p>
+          <a:p>
+            <a:pPr marL="0" indent="0">
+              <a:lnSpc>
+                <a:spcPct val="115000"/>
+              </a:lnSpc>
+              <a:buNone/>
+            </a:pPr>
+            <a:r>
+              <a:rPr lang="en-US" sz="850" dirty="0">
+                <a:solidFill>
+                  <a:srgbClr val="E2E8F0"/>
+                </a:solidFill>
+                <a:latin typeface="Consolas" pitchFamily="34" charset="0"/>
+                <a:ea typeface="Consolas" pitchFamily="34" charset="-122"/>
+                <a:cs typeface="Consolas" pitchFamily="34" charset="-120"/>
+              </a:rPr>
+              <a:t>        validate_and_parse_address,         # Address parsing</a:t>
+            </a:r>
+            <a:endParaRPr lang="en-US" sz="850" dirty="0"/>
+          </a:p>
+          <a:p>
+            <a:pPr marL="0" indent="0">
+              <a:lnSpc>
+                <a:spcPct val="115000"/>
+              </a:lnSpc>
+              <a:buNone/>
+            </a:pPr>
+            <a:r>
+              <a:rPr lang="en-US" sz="850" dirty="0">
+                <a:solidFill>
+                  <a:srgbClr val="E2E8F0"/>
+                </a:solidFill>
+                <a:latin typeface="Consolas" pitchFamily="34" charset="0"/>
+                <a:ea typeface="Consolas" pitchFamily="34" charset="-122"/>
+                <a:cs typeface="Consolas" pitchFamily="34" charset="-120"/>
+              </a:rPr>
+              <a:t>        check_service_availability,         # GIS / coverage lookup</a:t>
+            </a:r>
+            <a:endParaRPr lang="en-US" sz="850" dirty="0"/>
+          </a:p>
+          <a:p>
+            <a:pPr marL="0" indent="0">
+              <a:lnSpc>
+                <a:spcPct val="115000"/>
+              </a:lnSpc>
+              <a:buNone/>
+            </a:pPr>
+            <a:r>
+              <a:rPr lang="en-US" sz="850" dirty="0">
+                <a:solidFill>
+                  <a:srgbClr val="E2E8F0"/>
+                </a:solidFill>
+                <a:latin typeface="Consolas" pitchFamily="34" charset="0"/>
+                <a:ea typeface="Consolas" pitchFamily="34" charset="-122"/>
+                <a:cs typeface="Consolas" pitchFamily="34" charset="-120"/>
+              </a:rPr>
+              <a:t>        get_infrastructure_by_technology,   # Tech-specific details</a:t>
+            </a:r>
+            <a:endParaRPr lang="en-US" sz="850" dirty="0"/>
+          </a:p>
+          <a:p>
+            <a:pPr marL="0" indent="0">
+              <a:lnSpc>
+                <a:spcPct val="115000"/>
+              </a:lnSpc>
+              <a:buNone/>
+            </a:pPr>
+            <a:r>
+              <a:rPr lang="en-US" sz="850" dirty="0">
+                <a:solidFill>
+                  <a:srgbClr val="E2E8F0"/>
+                </a:solidFill>
+                <a:latin typeface="Consolas" pitchFamily="34" charset="0"/>
+                <a:ea typeface="Consolas" pitchFamily="34" charset="-122"/>
+                <a:cs typeface="Consolas" pitchFamily="34" charset="-120"/>
+              </a:rPr>
+              <a:t>    ],</a:t>
+            </a:r>
+            <a:endParaRPr lang="en-US" sz="850" dirty="0"/>
+          </a:p>
+          <a:p>
+            <a:pPr marL="0" indent="0">
+              <a:lnSpc>
+                <a:spcPct val="115000"/>
+              </a:lnSpc>
+              <a:buNone/>
+            </a:pPr>
+            <a:r>
+              <a:rPr lang="en-US" sz="850" dirty="0">
+                <a:solidFill>
+                  <a:srgbClr val="E2E8F0"/>
+                </a:solidFill>
+                <a:latin typeface="Consolas" pitchFamily="34" charset="0"/>
+                <a:ea typeface="Consolas" pitchFamily="34" charset="-122"/>
+                <a:cs typeface="Consolas" pitchFamily="34" charset="-120"/>
+              </a:rPr>
+              <a:t>    generate_content_config=types.GenerateContentConfig(</a:t>
+            </a:r>
+            <a:endParaRPr lang="en-US" sz="850" dirty="0"/>
+          </a:p>
+          <a:p>
+            <a:pPr marL="0" indent="0">
+              <a:lnSpc>
+                <a:spcPct val="115000"/>
+              </a:lnSpc>
+              <a:buNone/>
+            </a:pPr>
+            <a:r>
+              <a:rPr lang="en-US" sz="850" dirty="0">
+                <a:solidFill>
+                  <a:srgbClr val="E2E8F0"/>
+                </a:solidFill>
+                <a:latin typeface="Consolas" pitchFamily="34" charset="0"/>
+                <a:ea typeface="Consolas" pitchFamily="34" charset="-122"/>
+                <a:cs typeface="Consolas" pitchFamily="34" charset="-120"/>
+              </a:rPr>
+              <a:t>        temperature=0.0,   # Deterministic — no hallucination</a:t>
+            </a:r>
+            <a:endParaRPr lang="en-US" sz="850" dirty="0"/>
+          </a:p>
+          <a:p>
+            <a:pPr marL="0" indent="0">
+              <a:lnSpc>
+                <a:spcPct val="115000"/>
+              </a:lnSpc>
+              <a:buNone/>
+            </a:pPr>
+            <a:r>
+              <a:rPr lang="en-US" sz="850" dirty="0">
+                <a:solidFill>
+                  <a:srgbClr val="E2E8F0"/>
+                </a:solidFill>
+                <a:latin typeface="Consolas" pitchFamily="34" charset="0"/>
+                <a:ea typeface="Consolas" pitchFamily="34" charset="-122"/>
+                <a:cs typeface="Consolas" pitchFamily="34" charset="-120"/>
+              </a:rPr>
+              <a:t>        top_p=0.1,         # Very focused sampling</a:t>
+            </a:r>
+            <a:endParaRPr lang="en-US" sz="850" dirty="0"/>
+          </a:p>
+          <a:p>
+            <a:pPr marL="0" indent="0">
+              <a:lnSpc>
+                <a:spcPct val="115000"/>
+              </a:lnSpc>
+              <a:buNone/>
+            </a:pPr>
+            <a:r>
+              <a:rPr lang="en-US" sz="850" dirty="0">
+                <a:solidFill>
+                  <a:srgbClr val="E2E8F0"/>
+                </a:solidFill>
+                <a:latin typeface="Consolas" pitchFamily="34" charset="0"/>
+                <a:ea typeface="Consolas" pitchFamily="34" charset="-122"/>
+                <a:cs typeface="Consolas" pitchFamily="34" charset="-120"/>
+              </a:rPr>
+              <a:t>        top_k=10,          # Minimal token variation</a:t>
+            </a:r>
+            <a:endParaRPr lang="en-US" sz="850" dirty="0"/>
+          </a:p>
+          <a:p>
+            <a:pPr marL="0" indent="0">
+              <a:lnSpc>
+                <a:spcPct val="115000"/>
+              </a:lnSpc>
+              <a:buNone/>
+            </a:pPr>
+            <a:r>
+              <a:rPr lang="en-US" sz="850" dirty="0">
+                <a:solidFill>
+                  <a:srgbClr val="E2E8F0"/>
+                </a:solidFill>
+                <a:latin typeface="Consolas" pitchFamily="34" charset="0"/>
+                <a:ea typeface="Consolas" pitchFamily="34" charset="-122"/>
+                <a:cs typeface="Consolas" pitchFamily="34" charset="-120"/>
+              </a:rPr>
+              <a:t>        max_output_tokens=2048,</a:t>
+            </a:r>
+            <a:endParaRPr lang="en-US" sz="850" dirty="0"/>
+          </a:p>
+          <a:p>
+            <a:pPr marL="0" indent="0">
+              <a:lnSpc>
+                <a:spcPct val="115000"/>
+              </a:lnSpc>
+              <a:buNone/>
+            </a:pPr>
+            <a:r>
+              <a:rPr lang="en-US" sz="850" dirty="0">
+                <a:solidFill>
+                  <a:srgbClr val="E2E8F0"/>
+                </a:solidFill>
+                <a:latin typeface="Consolas" pitchFamily="34" charset="0"/>
+                <a:ea typeface="Consolas" pitchFamily="34" charset="-122"/>
+                <a:cs typeface="Consolas" pitchFamily="34" charset="-120"/>
+              </a:rPr>
+              <a:t>    ),</a:t>
+            </a:r>
+            <a:endParaRPr lang="en-US" sz="850" dirty="0"/>
+          </a:p>
+          <a:p>
+            <a:pPr marL="0" indent="0">
+              <a:lnSpc>
+                <a:spcPct val="115000"/>
+              </a:lnSpc>
+              <a:buNone/>
+            </a:pPr>
+            <a:r>
+              <a:rPr lang="en-US" sz="850" dirty="0">
+                <a:solidFill>
+                  <a:srgbClr val="E2E8F0"/>
+                </a:solidFill>
+                <a:latin typeface="Consolas" pitchFamily="34" charset="0"/>
+                <a:ea typeface="Consolas" pitchFamily="34" charset="-122"/>
+                <a:cs typeface="Consolas" pitchFamily="34" charset="-120"/>
+              </a:rPr>
+              <a:t>)</a:t>
+            </a:r>
+            <a:endParaRPr lang="en-US" sz="850" dirty="0"/>
+          </a:p>
+        </p:txBody>
+      </p:sp>
+    </p:spTree>
+  </p:cSld>
+  <p:clrMapOvr>
+    <a:masterClrMapping/>
+  </p:clrMapOvr>
+</p:sld>
+</file>
+
+<file path=ppt/slides/slide11.xml><?xml version="1.0" encoding="utf-8"?>
 <p:sld xmlns:a="http://schemas.openxmlformats.org/drawingml/2006/main" xmlns:r="http://schemas.openxmlformats.org/officeDocument/2006/relationships" xmlns:p="http://schemas.openxmlformats.org/presentationml/2006/main">
   <p:cSld name="Slide 9">
     <p:bg>
@@ -4592,7 +5387,7 @@
 </p:sld>
 </file>
 
-<file path=ppt/slides/slide11.xml><?xml version="1.0" encoding="utf-8"?>
+<file path=ppt/slides/slide12.xml><?xml version="1.0" encoding="utf-8"?>
 <p:sld xmlns:a="http://schemas.openxmlformats.org/drawingml/2006/main" xmlns:r="http://schemas.openxmlformats.org/officeDocument/2006/relationships" xmlns:p="http://schemas.openxmlformats.org/presentationml/2006/main">
   <p:cSld name="Slide 10">
     <p:bg>
@@ -5278,7 +6073,7 @@
 </p:sld>
 </file>
 
-<file path=ppt/slides/slide12.xml><?xml version="1.0" encoding="utf-8"?>
+<file path=ppt/slides/slide13.xml><?xml version="1.0" encoding="utf-8"?>
 <p:sld xmlns:a="http://schemas.openxmlformats.org/drawingml/2006/main" xmlns:r="http://schemas.openxmlformats.org/officeDocument/2006/relationships" xmlns:p="http://schemas.openxmlformats.org/presentationml/2006/main">
   <p:cSld name="Slide 11">
     <p:bg>
@@ -7329,7 +8124,7 @@
 </p:sld>
 </file>
 
-<file path=ppt/slides/slide13.xml><?xml version="1.0" encoding="utf-8"?>
+<file path=ppt/slides/slide14.xml><?xml version="1.0" encoding="utf-8"?>
 <p:sld xmlns:a="http://schemas.openxmlformats.org/drawingml/2006/main" xmlns:r="http://schemas.openxmlformats.org/officeDocument/2006/relationships" xmlns:p="http://schemas.openxmlformats.org/presentationml/2006/main">
   <p:cSld name="Slide 12">
     <p:bg>
@@ -8635,7 +9430,7 @@
 </p:sld>
 </file>
 
-<file path=ppt/slides/slide14.xml><?xml version="1.0" encoding="utf-8"?>
+<file path=ppt/slides/slide15.xml><?xml version="1.0" encoding="utf-8"?>
 <p:sld xmlns:a="http://schemas.openxmlformats.org/drawingml/2006/main" xmlns:r="http://schemas.openxmlformats.org/officeDocument/2006/relationships" xmlns:p="http://schemas.openxmlformats.org/presentationml/2006/main">
   <p:cSld name="Slide 13">
     <p:bg>
@@ -9798,7 +10593,7 @@
 </p:sld>
 </file>
 
-<file path=ppt/slides/slide15.xml><?xml version="1.0" encoding="utf-8"?>
+<file path=ppt/slides/slide16.xml><?xml version="1.0" encoding="utf-8"?>
 <p:sld xmlns:a="http://schemas.openxmlformats.org/drawingml/2006/main" xmlns:r="http://schemas.openxmlformats.org/officeDocument/2006/relationships" xmlns:p="http://schemas.openxmlformats.org/presentationml/2006/main">
   <p:cSld name="Slide 14">
     <p:bg>
@@ -10720,7 +11515,7 @@
 </p:sld>
 </file>
 
-<file path=ppt/slides/slide16.xml><?xml version="1.0" encoding="utf-8"?>
+<file path=ppt/slides/slide17.xml><?xml version="1.0" encoding="utf-8"?>
 <p:sld xmlns:a="http://schemas.openxmlformats.org/drawingml/2006/main" xmlns:r="http://schemas.openxmlformats.org/officeDocument/2006/relationships" xmlns:p="http://schemas.openxmlformats.org/presentationml/2006/main">
   <p:cSld name="Slide 15">
     <p:bg>
@@ -12185,7 +12980,7 @@
 </p:sld>
 </file>
 
-<file path=ppt/slides/slide17.xml><?xml version="1.0" encoding="utf-8"?>
+<file path=ppt/slides/slide18.xml><?xml version="1.0" encoding="utf-8"?>
 <p:sld xmlns:a="http://schemas.openxmlformats.org/drawingml/2006/main" xmlns:r="http://schemas.openxmlformats.org/officeDocument/2006/relationships" xmlns:p="http://schemas.openxmlformats.org/presentationml/2006/main">
   <p:cSld name="Slide 17">
     <p:bg>
@@ -17143,6 +17938,225 @@
 
 <file path=ppt/slides/slide5.xml><?xml version="1.0" encoding="utf-8"?>
 <p:sld xmlns:a="http://schemas.openxmlformats.org/drawingml/2006/main" xmlns:r="http://schemas.openxmlformats.org/officeDocument/2006/relationships" xmlns:p="http://schemas.openxmlformats.org/presentationml/2006/main">
+  <p:cSld>
+    <p:spTree>
+      <p:nvGrpSpPr>
+        <p:cNvPr id="1" name="">
+          <a:extLst>
+            <a:ext uri="{FF2B5EF4-FFF2-40B4-BE49-F238E27FC236}">
+              <a16:creationId xmlns:a16="http://schemas.microsoft.com/office/drawing/2014/main" id="{3A904FA5-3FA6-0914-0D48-643C631337E5}"/>
+            </a:ext>
+          </a:extLst>
+        </p:cNvPr>
+        <p:cNvGrpSpPr/>
+        <p:nvPr/>
+      </p:nvGrpSpPr>
+      <p:grpSpPr>
+        <a:xfrm>
+          <a:off x="0" y="0"/>
+          <a:ext cx="0" cy="0"/>
+          <a:chOff x="0" y="0"/>
+          <a:chExt cx="0" cy="0"/>
+        </a:xfrm>
+      </p:grpSpPr>
+      <p:sp>
+        <p:nvSpPr>
+          <p:cNvPr id="2" name="Shape 0">
+            <a:extLst>
+              <a:ext uri="{FF2B5EF4-FFF2-40B4-BE49-F238E27FC236}">
+                <a16:creationId xmlns:a16="http://schemas.microsoft.com/office/drawing/2014/main" id="{D04E2F01-AED0-821A-D06A-D9ADE3F76475}"/>
+              </a:ext>
+            </a:extLst>
+          </p:cNvPr>
+          <p:cNvSpPr/>
+          <p:nvPr/>
+        </p:nvSpPr>
+        <p:spPr>
+          <a:xfrm>
+            <a:off x="0" y="0"/>
+            <a:ext cx="9144000" cy="54864"/>
+          </a:xfrm>
+          <a:prstGeom prst="rect">
+            <a:avLst/>
+          </a:prstGeom>
+          <a:solidFill>
+            <a:srgbClr val="3B82F6"/>
+          </a:solidFill>
+          <a:ln/>
+        </p:spPr>
+        <p:txBody>
+          <a:bodyPr/>
+          <a:lstStyle/>
+          <a:p>
+            <a:endParaRPr lang="en-US"/>
+          </a:p>
+        </p:txBody>
+      </p:sp>
+      <p:sp>
+        <p:nvSpPr>
+          <p:cNvPr id="3" name="Text 1">
+            <a:extLst>
+              <a:ext uri="{FF2B5EF4-FFF2-40B4-BE49-F238E27FC236}">
+                <a16:creationId xmlns:a16="http://schemas.microsoft.com/office/drawing/2014/main" id="{F4B023DE-9DF8-1071-A7EC-BE4C3DAF662D}"/>
+              </a:ext>
+            </a:extLst>
+          </p:cNvPr>
+          <p:cNvSpPr/>
+          <p:nvPr/>
+        </p:nvSpPr>
+        <p:spPr>
+          <a:xfrm>
+            <a:off x="209666" y="-5819"/>
+            <a:ext cx="7863840" cy="502920"/>
+          </a:xfrm>
+          <a:prstGeom prst="rect">
+            <a:avLst/>
+          </a:prstGeom>
+          <a:noFill/>
+          <a:ln/>
+        </p:spPr>
+        <p:txBody>
+          <a:bodyPr wrap="square" lIns="0" tIns="0" rIns="0" bIns="0" rtlCol="0" anchor="ctr"/>
+          <a:lstStyle/>
+          <a:p>
+            <a:pPr marL="0" indent="0">
+              <a:buNone/>
+            </a:pPr>
+            <a:r>
+              <a:rPr lang="en-US" sz="2800" b="1" dirty="0">
+                <a:solidFill>
+                  <a:srgbClr val="1E293B"/>
+                </a:solidFill>
+                <a:latin typeface="Trebuchet MS" pitchFamily="34" charset="0"/>
+                <a:ea typeface="Trebuchet MS" pitchFamily="34" charset="-122"/>
+                <a:cs typeface="Trebuchet MS" pitchFamily="34" charset="-120"/>
+              </a:rPr>
+              <a:t>Architecture</a:t>
+            </a:r>
+            <a:endParaRPr lang="en-US" sz="2800" dirty="0"/>
+          </a:p>
+        </p:txBody>
+      </p:sp>
+      <p:sp>
+        <p:nvSpPr>
+          <p:cNvPr id="4" name="Text 2">
+            <a:extLst>
+              <a:ext uri="{FF2B5EF4-FFF2-40B4-BE49-F238E27FC236}">
+                <a16:creationId xmlns:a16="http://schemas.microsoft.com/office/drawing/2014/main" id="{A1A1E956-BAAC-368E-D2DC-423851C005C0}"/>
+              </a:ext>
+            </a:extLst>
+          </p:cNvPr>
+          <p:cNvSpPr/>
+          <p:nvPr/>
+        </p:nvSpPr>
+        <p:spPr>
+          <a:xfrm>
+            <a:off x="7772400" y="4754880"/>
+            <a:ext cx="1097280" cy="274320"/>
+          </a:xfrm>
+          <a:prstGeom prst="rect">
+            <a:avLst/>
+          </a:prstGeom>
+          <a:noFill/>
+          <a:ln/>
+        </p:spPr>
+        <p:txBody>
+          <a:bodyPr wrap="square" rtlCol="0" anchor="ctr"/>
+          <a:lstStyle/>
+          <a:p>
+            <a:pPr marL="0" indent="0" algn="r">
+              <a:buNone/>
+            </a:pPr>
+            <a:r>
+              <a:rPr lang="en-US" sz="900" dirty="0">
+                <a:solidFill>
+                  <a:srgbClr val="64748B"/>
+                </a:solidFill>
+                <a:latin typeface="Calibri" pitchFamily="34" charset="0"/>
+                <a:ea typeface="Calibri" pitchFamily="34" charset="-122"/>
+                <a:cs typeface="Calibri" pitchFamily="34" charset="-120"/>
+              </a:rPr>
+              <a:t>16 / 17</a:t>
+            </a:r>
+            <a:endParaRPr lang="en-US" sz="900" dirty="0"/>
+          </a:p>
+        </p:txBody>
+      </p:sp>
+      <p:pic>
+        <p:nvPicPr>
+          <p:cNvPr id="5" name="Image 0" descr="preencoded.png">
+            <a:extLst>
+              <a:ext uri="{FF2B5EF4-FFF2-40B4-BE49-F238E27FC236}">
+                <a16:creationId xmlns:a16="http://schemas.microsoft.com/office/drawing/2014/main" id="{90C7DE79-5999-BDBF-3978-3CB0C2A2C531}"/>
+              </a:ext>
+            </a:extLst>
+          </p:cNvPr>
+          <p:cNvPicPr>
+            <a:picLocks noChangeAspect="1"/>
+          </p:cNvPicPr>
+          <p:nvPr/>
+        </p:nvPicPr>
+        <p:blipFill>
+          <a:blip r:embed="rId3"/>
+          <a:stretch>
+            <a:fillRect/>
+          </a:stretch>
+        </p:blipFill>
+        <p:spPr>
+          <a:xfrm>
+            <a:off x="8321040" y="274320"/>
+            <a:ext cx="411480" cy="411480"/>
+          </a:xfrm>
+          <a:prstGeom prst="rect">
+            <a:avLst/>
+          </a:prstGeom>
+        </p:spPr>
+      </p:pic>
+      <p:pic>
+        <p:nvPicPr>
+          <p:cNvPr id="6" name="Picture 5" descr="A screenshot of a computer&#10;&#10;AI-generated content may be incorrect.">
+            <a:extLst>
+              <a:ext uri="{FF2B5EF4-FFF2-40B4-BE49-F238E27FC236}">
+                <a16:creationId xmlns:a16="http://schemas.microsoft.com/office/drawing/2014/main" id="{619E1F93-FCD3-E0F8-B69E-3666032D08AD}"/>
+              </a:ext>
+            </a:extLst>
+          </p:cNvPr>
+          <p:cNvPicPr>
+            <a:picLocks noChangeAspect="1"/>
+          </p:cNvPicPr>
+          <p:nvPr/>
+        </p:nvPicPr>
+        <p:blipFill>
+          <a:blip r:embed="rId4"/>
+          <a:stretch>
+            <a:fillRect/>
+          </a:stretch>
+        </p:blipFill>
+        <p:spPr>
+          <a:xfrm>
+            <a:off x="370379" y="480060"/>
+            <a:ext cx="7278254" cy="4535911"/>
+          </a:xfrm>
+          <a:prstGeom prst="rect">
+            <a:avLst/>
+          </a:prstGeom>
+        </p:spPr>
+      </p:pic>
+    </p:spTree>
+    <p:extLst>
+      <p:ext uri="{BB962C8B-B14F-4D97-AF65-F5344CB8AC3E}">
+        <p14:creationId xmlns:p14="http://schemas.microsoft.com/office/powerpoint/2010/main" val="3466633268"/>
+      </p:ext>
+    </p:extLst>
+  </p:cSld>
+  <p:clrMapOvr>
+    <a:masterClrMapping/>
+  </p:clrMapOvr>
+</p:sld>
+</file>
+
+<file path=ppt/slides/slide6.xml><?xml version="1.0" encoding="utf-8"?>
+<p:sld xmlns:a="http://schemas.openxmlformats.org/drawingml/2006/main" xmlns:r="http://schemas.openxmlformats.org/officeDocument/2006/relationships" xmlns:p="http://schemas.openxmlformats.org/presentationml/2006/main">
   <p:cSld name="Slide 16">
     <p:bg>
       <p:bgPr>
@@ -17637,18 +18651,7 @@
                           <a:ea typeface="Calibri" pitchFamily="34" charset="-122"/>
                           <a:cs typeface="Calibri" pitchFamily="34" charset="-120"/>
                         </a:rPr>
-                        <a:t>Google Gemini 3 </a:t>
-                      </a:r>
-                      <a:r>
-                        <a:rPr lang="en-US" sz="1050" b="1">
-                          <a:solidFill>
-                            <a:srgbClr val="1E293B"/>
-                          </a:solidFill>
-                          <a:latin typeface="Calibri" pitchFamily="34" charset="0"/>
-                          <a:ea typeface="Calibri" pitchFamily="34" charset="-122"/>
-                          <a:cs typeface="Calibri" pitchFamily="34" charset="-120"/>
-                        </a:rPr>
-                        <a:t>Flash Preview</a:t>
+                        <a:t>Google Gemini 3 Flash Preview</a:t>
                       </a:r>
                       <a:endParaRPr lang="en-US" sz="1050" dirty="0">
                         <a:latin typeface="Calibri" charset="0"/>
@@ -19051,7 +20054,7 @@
 </p:sld>
 </file>
 
-<file path=ppt/slides/slide6.xml><?xml version="1.0" encoding="utf-8"?>
+<file path=ppt/slides/slide7.xml><?xml version="1.0" encoding="utf-8"?>
 <p:sld xmlns:a="http://schemas.openxmlformats.org/drawingml/2006/main" xmlns:r="http://schemas.openxmlformats.org/officeDocument/2006/relationships" xmlns:p="http://schemas.openxmlformats.org/presentationml/2006/main">
   <p:cSld name="Slide 5">
     <p:bg>
@@ -20740,7 +21743,7 @@
 </p:sld>
 </file>
 
-<file path=ppt/slides/slide7.xml><?xml version="1.0" encoding="utf-8"?>
+<file path=ppt/slides/slide8.xml><?xml version="1.0" encoding="utf-8"?>
 <p:sld xmlns:a="http://schemas.openxmlformats.org/drawingml/2006/main" xmlns:r="http://schemas.openxmlformats.org/officeDocument/2006/relationships" xmlns:p="http://schemas.openxmlformats.org/presentationml/2006/main">
   <p:cSld name="Slide 6">
     <p:bg>
@@ -21446,7 +22449,7 @@
 </p:sld>
 </file>
 
-<file path=ppt/slides/slide8.xml><?xml version="1.0" encoding="utf-8"?>
+<file path=ppt/slides/slide9.xml><?xml version="1.0" encoding="utf-8"?>
 <p:sld xmlns:a="http://schemas.openxmlformats.org/drawingml/2006/main" xmlns:r="http://schemas.openxmlformats.org/officeDocument/2006/relationships" xmlns:p="http://schemas.openxmlformats.org/presentationml/2006/main">
   <p:cSld name="Slide 7">
     <p:bg>
@@ -22554,692 +23557,6 @@
               <a:t>transfer_to_agent is an ADK-native function</a:t>
             </a:r>
             <a:endParaRPr lang="en-US" sz="900" dirty="0"/>
-          </a:p>
-        </p:txBody>
-      </p:sp>
-    </p:spTree>
-  </p:cSld>
-  <p:clrMapOvr>
-    <a:masterClrMapping/>
-  </p:clrMapOvr>
-</p:sld>
-</file>
-
-<file path=ppt/slides/slide9.xml><?xml version="1.0" encoding="utf-8"?>
-<p:sld xmlns:a="http://schemas.openxmlformats.org/drawingml/2006/main" xmlns:r="http://schemas.openxmlformats.org/officeDocument/2006/relationships" xmlns:p="http://schemas.openxmlformats.org/presentationml/2006/main">
-  <p:cSld name="Slide 8">
-    <p:bg>
-      <p:bgPr>
-        <a:solidFill>
-          <a:srgbClr val="0B1120"/>
-        </a:solidFill>
-        <a:effectLst/>
-      </p:bgPr>
-    </p:bg>
-    <p:spTree>
-      <p:nvGrpSpPr>
-        <p:cNvPr id="1" name=""/>
-        <p:cNvGrpSpPr/>
-        <p:nvPr/>
-      </p:nvGrpSpPr>
-      <p:grpSpPr>
-        <a:xfrm>
-          <a:off x="0" y="0"/>
-          <a:ext cx="0" cy="0"/>
-          <a:chOff x="0" y="0"/>
-          <a:chExt cx="0" cy="0"/>
-        </a:xfrm>
-      </p:grpSpPr>
-      <p:sp>
-        <p:nvSpPr>
-          <p:cNvPr id="2" name="Text 0"/>
-          <p:cNvSpPr/>
-          <p:nvPr/>
-        </p:nvSpPr>
-        <p:spPr>
-          <a:xfrm>
-            <a:off x="640080" y="274320"/>
-            <a:ext cx="7863840" cy="502920"/>
-          </a:xfrm>
-          <a:prstGeom prst="rect">
-            <a:avLst/>
-          </a:prstGeom>
-          <a:noFill/>
-          <a:ln/>
-        </p:spPr>
-        <p:txBody>
-          <a:bodyPr wrap="square" lIns="0" tIns="0" rIns="0" bIns="0" rtlCol="0" anchor="ctr"/>
-          <a:lstStyle/>
-          <a:p>
-            <a:pPr marL="0" indent="0">
-              <a:buNone/>
-            </a:pPr>
-            <a:r>
-              <a:rPr lang="en-US" sz="2800" b="1" dirty="0">
-                <a:solidFill>
-                  <a:srgbClr val="E2E8F0"/>
-                </a:solidFill>
-                <a:latin typeface="Trebuchet MS" pitchFamily="34" charset="0"/>
-                <a:ea typeface="Trebuchet MS" pitchFamily="34" charset="-122"/>
-                <a:cs typeface="Trebuchet MS" pitchFamily="34" charset="-120"/>
-              </a:rPr>
-              <a:t>Code: Sub-Agent — Deterministic Agent Pattern</a:t>
-            </a:r>
-            <a:endParaRPr lang="en-US" sz="2800" dirty="0"/>
-          </a:p>
-        </p:txBody>
-      </p:sp>
-      <p:sp>
-        <p:nvSpPr>
-          <p:cNvPr id="3" name="Text 1"/>
-          <p:cNvSpPr/>
-          <p:nvPr/>
-        </p:nvSpPr>
-        <p:spPr>
-          <a:xfrm>
-            <a:off x="7772400" y="4754880"/>
-            <a:ext cx="1097280" cy="274320"/>
-          </a:xfrm>
-          <a:prstGeom prst="rect">
-            <a:avLst/>
-          </a:prstGeom>
-          <a:noFill/>
-          <a:ln/>
-        </p:spPr>
-        <p:txBody>
-          <a:bodyPr wrap="square" rtlCol="0" anchor="ctr"/>
-          <a:lstStyle/>
-          <a:p>
-            <a:pPr marL="0" indent="0" algn="r">
-              <a:buNone/>
-            </a:pPr>
-            <a:r>
-              <a:rPr lang="en-US" sz="900" dirty="0">
-                <a:solidFill>
-                  <a:srgbClr val="94A3B8"/>
-                </a:solidFill>
-                <a:latin typeface="Calibri" pitchFamily="34" charset="0"/>
-                <a:ea typeface="Calibri" pitchFamily="34" charset="-122"/>
-                <a:cs typeface="Calibri" pitchFamily="34" charset="-120"/>
-              </a:rPr>
-              <a:t>8 / 17</a:t>
-            </a:r>
-            <a:endParaRPr lang="en-US" sz="900" dirty="0"/>
-          </a:p>
-        </p:txBody>
-      </p:sp>
-      <p:sp>
-        <p:nvSpPr>
-          <p:cNvPr id="4" name="Text 2"/>
-          <p:cNvSpPr/>
-          <p:nvPr/>
-        </p:nvSpPr>
-        <p:spPr>
-          <a:xfrm>
-            <a:off x="640080" y="777240"/>
-            <a:ext cx="7863840" cy="320040"/>
-          </a:xfrm>
-          <a:prstGeom prst="rect">
-            <a:avLst/>
-          </a:prstGeom>
-          <a:noFill/>
-          <a:ln/>
-        </p:spPr>
-        <p:txBody>
-          <a:bodyPr wrap="square" lIns="0" tIns="0" rIns="0" bIns="0" rtlCol="0" anchor="ctr"/>
-          <a:lstStyle/>
-          <a:p>
-            <a:pPr marL="0" indent="0">
-              <a:buNone/>
-            </a:pPr>
-            <a:r>
-              <a:rPr lang="en-US" sz="1100" i="1" dirty="0">
-                <a:solidFill>
-                  <a:srgbClr val="94A3B8"/>
-                </a:solidFill>
-                <a:latin typeface="Calibri" pitchFamily="34" charset="0"/>
-                <a:ea typeface="Calibri" pitchFamily="34" charset="-122"/>
-                <a:cs typeface="Calibri" pitchFamily="34" charset="-120"/>
-              </a:rPr>
-              <a:t>Sub-agents like ServiceabilityAgent use temperature 0.0 for deterministic, tool-based responses.</a:t>
-            </a:r>
-            <a:endParaRPr lang="en-US" sz="1100" dirty="0"/>
-          </a:p>
-        </p:txBody>
-      </p:sp>
-      <p:sp>
-        <p:nvSpPr>
-          <p:cNvPr id="5" name="Shape 3"/>
-          <p:cNvSpPr/>
-          <p:nvPr/>
-        </p:nvSpPr>
-        <p:spPr>
-          <a:xfrm>
-            <a:off x="457200" y="1188720"/>
-            <a:ext cx="8229600" cy="3657600"/>
-          </a:xfrm>
-          <a:prstGeom prst="rect">
-            <a:avLst/>
-          </a:prstGeom>
-          <a:solidFill>
-            <a:srgbClr val="0F172A"/>
-          </a:solidFill>
-          <a:ln/>
-          <a:effectLst>
-            <a:outerShdw blurRad="76200" dist="25400" dir="8100000" algn="bl" rotWithShape="0">
-              <a:srgbClr val="000000">
-                <a:alpha val="12000"/>
-              </a:srgbClr>
-            </a:outerShdw>
-          </a:effectLst>
-        </p:spPr>
-        <p:txBody>
-          <a:bodyPr/>
-          <a:lstStyle/>
-          <a:p>
-            <a:endParaRPr lang="en-US"/>
-          </a:p>
-        </p:txBody>
-      </p:sp>
-      <p:sp>
-        <p:nvSpPr>
-          <p:cNvPr id="6" name="Text 4"/>
-          <p:cNvSpPr/>
-          <p:nvPr/>
-        </p:nvSpPr>
-        <p:spPr>
-          <a:xfrm>
-            <a:off x="594360" y="1280160"/>
-            <a:ext cx="7955280" cy="3474720"/>
-          </a:xfrm>
-          <a:prstGeom prst="rect">
-            <a:avLst/>
-          </a:prstGeom>
-          <a:noFill/>
-          <a:ln/>
-        </p:spPr>
-        <p:txBody>
-          <a:bodyPr wrap="square" rtlCol="0" anchor="t"/>
-          <a:lstStyle/>
-          <a:p>
-            <a:pPr marL="0" indent="0">
-              <a:lnSpc>
-                <a:spcPct val="115000"/>
-              </a:lnSpc>
-              <a:buNone/>
-            </a:pPr>
-            <a:r>
-              <a:rPr lang="en-US" sz="850" dirty="0">
-                <a:solidFill>
-                  <a:srgbClr val="C586C0"/>
-                </a:solidFill>
-                <a:latin typeface="Consolas" pitchFamily="34" charset="0"/>
-                <a:ea typeface="Consolas" pitchFamily="34" charset="-122"/>
-                <a:cs typeface="Consolas" pitchFamily="34" charset="-120"/>
-              </a:rPr>
-              <a:t>from google.adk.agents import Agent</a:t>
-            </a:r>
-            <a:endParaRPr lang="en-US" sz="850" dirty="0"/>
-          </a:p>
-          <a:p>
-            <a:pPr marL="0" indent="0">
-              <a:lnSpc>
-                <a:spcPct val="115000"/>
-              </a:lnSpc>
-              <a:buNone/>
-            </a:pPr>
-            <a:r>
-              <a:rPr lang="en-US" sz="850" dirty="0">
-                <a:solidFill>
-                  <a:srgbClr val="C586C0"/>
-                </a:solidFill>
-                <a:latin typeface="Consolas" pitchFamily="34" charset="0"/>
-                <a:ea typeface="Consolas" pitchFamily="34" charset="-122"/>
-                <a:cs typeface="Consolas" pitchFamily="34" charset="-120"/>
-              </a:rPr>
-              <a:t>from google.genai import types</a:t>
-            </a:r>
-            <a:endParaRPr lang="en-US" sz="850" dirty="0"/>
-          </a:p>
-          <a:p>
-            <a:pPr marL="0" indent="0">
-              <a:lnSpc>
-                <a:spcPct val="115000"/>
-              </a:lnSpc>
-              <a:buNone/>
-            </a:pPr>
-            <a:r>
-              <a:rPr lang="en-US" sz="850" dirty="0">
-                <a:solidFill>
-                  <a:srgbClr val="C586C0"/>
-                </a:solidFill>
-                <a:latin typeface="Consolas" pitchFamily="34" charset="0"/>
-                <a:ea typeface="Consolas" pitchFamily="34" charset="-122"/>
-                <a:cs typeface="Consolas" pitchFamily="34" charset="-120"/>
-              </a:rPr>
-              <a:t>from .tools.gis_tools import check_service_availability</a:t>
-            </a:r>
-            <a:endParaRPr lang="en-US" sz="850" dirty="0"/>
-          </a:p>
-          <a:p>
-            <a:pPr marL="0" indent="0">
-              <a:lnSpc>
-                <a:spcPct val="115000"/>
-              </a:lnSpc>
-              <a:buNone/>
-            </a:pPr>
-            <a:r>
-              <a:rPr lang="en-US" sz="850" dirty="0">
-                <a:solidFill>
-                  <a:srgbClr val="E2E8F0"/>
-                </a:solidFill>
-                <a:latin typeface="Consolas" pitchFamily="34" charset="0"/>
-                <a:ea typeface="Consolas" pitchFamily="34" charset="-122"/>
-                <a:cs typeface="Consolas" pitchFamily="34" charset="-120"/>
-              </a:rPr>
-              <a:t> </a:t>
-            </a:r>
-            <a:endParaRPr lang="en-US" sz="850" dirty="0"/>
-          </a:p>
-          <a:p>
-            <a:pPr marL="0" indent="0">
-              <a:lnSpc>
-                <a:spcPct val="115000"/>
-              </a:lnSpc>
-              <a:buNone/>
-            </a:pPr>
-            <a:r>
-              <a:rPr lang="en-US" sz="850" dirty="0">
-                <a:solidFill>
-                  <a:srgbClr val="6A9955"/>
-                </a:solidFill>
-                <a:latin typeface="Consolas" pitchFamily="34" charset="0"/>
-                <a:ea typeface="Consolas" pitchFamily="34" charset="-122"/>
-                <a:cs typeface="Consolas" pitchFamily="34" charset="-120"/>
-              </a:rPr>
-              <a:t># Hardcoded name — never read from .env to avoid conflicts</a:t>
-            </a:r>
-            <a:endParaRPr lang="en-US" sz="850" dirty="0"/>
-          </a:p>
-          <a:p>
-            <a:pPr marL="0" indent="0">
-              <a:lnSpc>
-                <a:spcPct val="115000"/>
-              </a:lnSpc>
-              <a:buNone/>
-            </a:pPr>
-            <a:r>
-              <a:rPr lang="en-US" sz="850" dirty="0">
-                <a:solidFill>
-                  <a:srgbClr val="CE9178"/>
-                </a:solidFill>
-                <a:latin typeface="Consolas" pitchFamily="34" charset="0"/>
-                <a:ea typeface="Consolas" pitchFamily="34" charset="-122"/>
-                <a:cs typeface="Consolas" pitchFamily="34" charset="-120"/>
-              </a:rPr>
-              <a:t>GEMINI_MODEL = os.getenv("GEMINI_MODEL")</a:t>
-            </a:r>
-            <a:endParaRPr lang="en-US" sz="850" dirty="0"/>
-          </a:p>
-          <a:p>
-            <a:pPr marL="0" indent="0">
-              <a:lnSpc>
-                <a:spcPct val="115000"/>
-              </a:lnSpc>
-              <a:buNone/>
-            </a:pPr>
-            <a:r>
-              <a:rPr lang="en-US" sz="850" dirty="0">
-                <a:solidFill>
-                  <a:srgbClr val="E2E8F0"/>
-                </a:solidFill>
-                <a:latin typeface="Consolas" pitchFamily="34" charset="0"/>
-                <a:ea typeface="Consolas" pitchFamily="34" charset="-122"/>
-                <a:cs typeface="Consolas" pitchFamily="34" charset="-120"/>
-              </a:rPr>
-              <a:t> </a:t>
-            </a:r>
-            <a:endParaRPr lang="en-US" sz="850" dirty="0"/>
-          </a:p>
-          <a:p>
-            <a:pPr marL="0" indent="0">
-              <a:lnSpc>
-                <a:spcPct val="115000"/>
-              </a:lnSpc>
-              <a:buNone/>
-            </a:pPr>
-            <a:r>
-              <a:rPr lang="en-US" sz="850" dirty="0">
-                <a:solidFill>
-                  <a:srgbClr val="E2E8F0"/>
-                </a:solidFill>
-                <a:latin typeface="Consolas" pitchFamily="34" charset="0"/>
-                <a:ea typeface="Consolas" pitchFamily="34" charset="-122"/>
-                <a:cs typeface="Consolas" pitchFamily="34" charset="-120"/>
-              </a:rPr>
-              <a:t>serviceability_agent = Agent(</a:t>
-            </a:r>
-            <a:endParaRPr lang="en-US" sz="850" dirty="0"/>
-          </a:p>
-          <a:p>
-            <a:pPr marL="0" indent="0">
-              <a:lnSpc>
-                <a:spcPct val="115000"/>
-              </a:lnSpc>
-              <a:buNone/>
-            </a:pPr>
-            <a:r>
-              <a:rPr lang="en-US" sz="850" dirty="0">
-                <a:solidFill>
-                  <a:srgbClr val="CE9178"/>
-                </a:solidFill>
-                <a:latin typeface="Consolas" pitchFamily="34" charset="0"/>
-                <a:ea typeface="Consolas" pitchFamily="34" charset="-122"/>
-                <a:cs typeface="Consolas" pitchFamily="34" charset="-120"/>
-              </a:rPr>
-              <a:t>    name="serviceability_agent",            # Hardcoded, not from env var</a:t>
-            </a:r>
-            <a:endParaRPr lang="en-US" sz="850" dirty="0"/>
-          </a:p>
-          <a:p>
-            <a:pPr marL="0" indent="0">
-              <a:lnSpc>
-                <a:spcPct val="115000"/>
-              </a:lnSpc>
-              <a:buNone/>
-            </a:pPr>
-            <a:r>
-              <a:rPr lang="en-US" sz="850" dirty="0">
-                <a:solidFill>
-                  <a:srgbClr val="E2E8F0"/>
-                </a:solidFill>
-                <a:latin typeface="Consolas" pitchFamily="34" charset="0"/>
-                <a:ea typeface="Consolas" pitchFamily="34" charset="-122"/>
-                <a:cs typeface="Consolas" pitchFamily="34" charset="-120"/>
-              </a:rPr>
-              <a:t>    model=GEMINI_MODEL,</a:t>
-            </a:r>
-            <a:endParaRPr lang="en-US" sz="850" dirty="0"/>
-          </a:p>
-          <a:p>
-            <a:pPr marL="0" indent="0">
-              <a:lnSpc>
-                <a:spcPct val="115000"/>
-              </a:lnSpc>
-              <a:buNone/>
-            </a:pPr>
-            <a:r>
-              <a:rPr lang="en-US" sz="850" dirty="0">
-                <a:solidFill>
-                  <a:srgbClr val="E2E8F0"/>
-                </a:solidFill>
-                <a:latin typeface="Consolas" pitchFamily="34" charset="0"/>
-                <a:ea typeface="Consolas" pitchFamily="34" charset="-122"/>
-                <a:cs typeface="Consolas" pitchFamily="34" charset="-120"/>
-              </a:rPr>
-              <a:t>    instruction=SERVICEABILITY_INSTRUCTION, # Domain-specific prompt</a:t>
-            </a:r>
-            <a:endParaRPr lang="en-US" sz="850" dirty="0"/>
-          </a:p>
-          <a:p>
-            <a:pPr marL="0" indent="0">
-              <a:lnSpc>
-                <a:spcPct val="115000"/>
-              </a:lnSpc>
-              <a:buNone/>
-            </a:pPr>
-            <a:r>
-              <a:rPr lang="en-US" sz="850" dirty="0">
-                <a:solidFill>
-                  <a:srgbClr val="CE9178"/>
-                </a:solidFill>
-                <a:latin typeface="Consolas" pitchFamily="34" charset="0"/>
-                <a:ea typeface="Consolas" pitchFamily="34" charset="-122"/>
-                <a:cs typeface="Consolas" pitchFamily="34" charset="-120"/>
-              </a:rPr>
-              <a:t>    description="PRE-SALE address validation &amp; coverage check",</a:t>
-            </a:r>
-            <a:endParaRPr lang="en-US" sz="850" dirty="0"/>
-          </a:p>
-          <a:p>
-            <a:pPr marL="0" indent="0">
-              <a:lnSpc>
-                <a:spcPct val="115000"/>
-              </a:lnSpc>
-              <a:buNone/>
-            </a:pPr>
-            <a:r>
-              <a:rPr lang="en-US" sz="850" dirty="0">
-                <a:solidFill>
-                  <a:srgbClr val="E2E8F0"/>
-                </a:solidFill>
-                <a:latin typeface="Consolas" pitchFamily="34" charset="0"/>
-                <a:ea typeface="Consolas" pitchFamily="34" charset="-122"/>
-                <a:cs typeface="Consolas" pitchFamily="34" charset="-120"/>
-              </a:rPr>
-              <a:t>    tools=[</a:t>
-            </a:r>
-            <a:endParaRPr lang="en-US" sz="850" dirty="0"/>
-          </a:p>
-          <a:p>
-            <a:pPr marL="0" indent="0">
-              <a:lnSpc>
-                <a:spcPct val="115000"/>
-              </a:lnSpc>
-              <a:buNone/>
-            </a:pPr>
-            <a:r>
-              <a:rPr lang="en-US" sz="850" dirty="0">
-                <a:solidFill>
-                  <a:srgbClr val="E2E8F0"/>
-                </a:solidFill>
-                <a:latin typeface="Consolas" pitchFamily="34" charset="0"/>
-                <a:ea typeface="Consolas" pitchFamily="34" charset="-122"/>
-                <a:cs typeface="Consolas" pitchFamily="34" charset="-120"/>
-              </a:rPr>
-              <a:t>        validate_and_parse_address,         # Address parsing</a:t>
-            </a:r>
-            <a:endParaRPr lang="en-US" sz="850" dirty="0"/>
-          </a:p>
-          <a:p>
-            <a:pPr marL="0" indent="0">
-              <a:lnSpc>
-                <a:spcPct val="115000"/>
-              </a:lnSpc>
-              <a:buNone/>
-            </a:pPr>
-            <a:r>
-              <a:rPr lang="en-US" sz="850" dirty="0">
-                <a:solidFill>
-                  <a:srgbClr val="E2E8F0"/>
-                </a:solidFill>
-                <a:latin typeface="Consolas" pitchFamily="34" charset="0"/>
-                <a:ea typeface="Consolas" pitchFamily="34" charset="-122"/>
-                <a:cs typeface="Consolas" pitchFamily="34" charset="-120"/>
-              </a:rPr>
-              <a:t>        check_service_availability,         # GIS / coverage lookup</a:t>
-            </a:r>
-            <a:endParaRPr lang="en-US" sz="850" dirty="0"/>
-          </a:p>
-          <a:p>
-            <a:pPr marL="0" indent="0">
-              <a:lnSpc>
-                <a:spcPct val="115000"/>
-              </a:lnSpc>
-              <a:buNone/>
-            </a:pPr>
-            <a:r>
-              <a:rPr lang="en-US" sz="850" dirty="0">
-                <a:solidFill>
-                  <a:srgbClr val="E2E8F0"/>
-                </a:solidFill>
-                <a:latin typeface="Consolas" pitchFamily="34" charset="0"/>
-                <a:ea typeface="Consolas" pitchFamily="34" charset="-122"/>
-                <a:cs typeface="Consolas" pitchFamily="34" charset="-120"/>
-              </a:rPr>
-              <a:t>        get_infrastructure_by_technology,   # Tech-specific details</a:t>
-            </a:r>
-            <a:endParaRPr lang="en-US" sz="850" dirty="0"/>
-          </a:p>
-          <a:p>
-            <a:pPr marL="0" indent="0">
-              <a:lnSpc>
-                <a:spcPct val="115000"/>
-              </a:lnSpc>
-              <a:buNone/>
-            </a:pPr>
-            <a:r>
-              <a:rPr lang="en-US" sz="850" dirty="0">
-                <a:solidFill>
-                  <a:srgbClr val="E2E8F0"/>
-                </a:solidFill>
-                <a:latin typeface="Consolas" pitchFamily="34" charset="0"/>
-                <a:ea typeface="Consolas" pitchFamily="34" charset="-122"/>
-                <a:cs typeface="Consolas" pitchFamily="34" charset="-120"/>
-              </a:rPr>
-              <a:t>    ],</a:t>
-            </a:r>
-            <a:endParaRPr lang="en-US" sz="850" dirty="0"/>
-          </a:p>
-          <a:p>
-            <a:pPr marL="0" indent="0">
-              <a:lnSpc>
-                <a:spcPct val="115000"/>
-              </a:lnSpc>
-              <a:buNone/>
-            </a:pPr>
-            <a:r>
-              <a:rPr lang="en-US" sz="850" dirty="0">
-                <a:solidFill>
-                  <a:srgbClr val="E2E8F0"/>
-                </a:solidFill>
-                <a:latin typeface="Consolas" pitchFamily="34" charset="0"/>
-                <a:ea typeface="Consolas" pitchFamily="34" charset="-122"/>
-                <a:cs typeface="Consolas" pitchFamily="34" charset="-120"/>
-              </a:rPr>
-              <a:t>    generate_content_config=types.GenerateContentConfig(</a:t>
-            </a:r>
-            <a:endParaRPr lang="en-US" sz="850" dirty="0"/>
-          </a:p>
-          <a:p>
-            <a:pPr marL="0" indent="0">
-              <a:lnSpc>
-                <a:spcPct val="115000"/>
-              </a:lnSpc>
-              <a:buNone/>
-            </a:pPr>
-            <a:r>
-              <a:rPr lang="en-US" sz="850" dirty="0">
-                <a:solidFill>
-                  <a:srgbClr val="E2E8F0"/>
-                </a:solidFill>
-                <a:latin typeface="Consolas" pitchFamily="34" charset="0"/>
-                <a:ea typeface="Consolas" pitchFamily="34" charset="-122"/>
-                <a:cs typeface="Consolas" pitchFamily="34" charset="-120"/>
-              </a:rPr>
-              <a:t>        temperature=0.0,   # Deterministic — no hallucination</a:t>
-            </a:r>
-            <a:endParaRPr lang="en-US" sz="850" dirty="0"/>
-          </a:p>
-          <a:p>
-            <a:pPr marL="0" indent="0">
-              <a:lnSpc>
-                <a:spcPct val="115000"/>
-              </a:lnSpc>
-              <a:buNone/>
-            </a:pPr>
-            <a:r>
-              <a:rPr lang="en-US" sz="850" dirty="0">
-                <a:solidFill>
-                  <a:srgbClr val="E2E8F0"/>
-                </a:solidFill>
-                <a:latin typeface="Consolas" pitchFamily="34" charset="0"/>
-                <a:ea typeface="Consolas" pitchFamily="34" charset="-122"/>
-                <a:cs typeface="Consolas" pitchFamily="34" charset="-120"/>
-              </a:rPr>
-              <a:t>        top_p=0.1,         # Very focused sampling</a:t>
-            </a:r>
-            <a:endParaRPr lang="en-US" sz="850" dirty="0"/>
-          </a:p>
-          <a:p>
-            <a:pPr marL="0" indent="0">
-              <a:lnSpc>
-                <a:spcPct val="115000"/>
-              </a:lnSpc>
-              <a:buNone/>
-            </a:pPr>
-            <a:r>
-              <a:rPr lang="en-US" sz="850" dirty="0">
-                <a:solidFill>
-                  <a:srgbClr val="E2E8F0"/>
-                </a:solidFill>
-                <a:latin typeface="Consolas" pitchFamily="34" charset="0"/>
-                <a:ea typeface="Consolas" pitchFamily="34" charset="-122"/>
-                <a:cs typeface="Consolas" pitchFamily="34" charset="-120"/>
-              </a:rPr>
-              <a:t>        top_k=10,          # Minimal token variation</a:t>
-            </a:r>
-            <a:endParaRPr lang="en-US" sz="850" dirty="0"/>
-          </a:p>
-          <a:p>
-            <a:pPr marL="0" indent="0">
-              <a:lnSpc>
-                <a:spcPct val="115000"/>
-              </a:lnSpc>
-              <a:buNone/>
-            </a:pPr>
-            <a:r>
-              <a:rPr lang="en-US" sz="850" dirty="0">
-                <a:solidFill>
-                  <a:srgbClr val="E2E8F0"/>
-                </a:solidFill>
-                <a:latin typeface="Consolas" pitchFamily="34" charset="0"/>
-                <a:ea typeface="Consolas" pitchFamily="34" charset="-122"/>
-                <a:cs typeface="Consolas" pitchFamily="34" charset="-120"/>
-              </a:rPr>
-              <a:t>        max_output_tokens=2048,</a:t>
-            </a:r>
-            <a:endParaRPr lang="en-US" sz="850" dirty="0"/>
-          </a:p>
-          <a:p>
-            <a:pPr marL="0" indent="0">
-              <a:lnSpc>
-                <a:spcPct val="115000"/>
-              </a:lnSpc>
-              <a:buNone/>
-            </a:pPr>
-            <a:r>
-              <a:rPr lang="en-US" sz="850" dirty="0">
-                <a:solidFill>
-                  <a:srgbClr val="E2E8F0"/>
-                </a:solidFill>
-                <a:latin typeface="Consolas" pitchFamily="34" charset="0"/>
-                <a:ea typeface="Consolas" pitchFamily="34" charset="-122"/>
-                <a:cs typeface="Consolas" pitchFamily="34" charset="-120"/>
-              </a:rPr>
-              <a:t>    ),</a:t>
-            </a:r>
-            <a:endParaRPr lang="en-US" sz="850" dirty="0"/>
-          </a:p>
-          <a:p>
-            <a:pPr marL="0" indent="0">
-              <a:lnSpc>
-                <a:spcPct val="115000"/>
-              </a:lnSpc>
-              <a:buNone/>
-            </a:pPr>
-            <a:r>
-              <a:rPr lang="en-US" sz="850" dirty="0">
-                <a:solidFill>
-                  <a:srgbClr val="E2E8F0"/>
-                </a:solidFill>
-                <a:latin typeface="Consolas" pitchFamily="34" charset="0"/>
-                <a:ea typeface="Consolas" pitchFamily="34" charset="-122"/>
-                <a:cs typeface="Consolas" pitchFamily="34" charset="-120"/>
-              </a:rPr>
-              <a:t>)</a:t>
-            </a:r>
-            <a:endParaRPr lang="en-US" sz="850" dirty="0"/>
           </a:p>
         </p:txBody>
       </p:sp>

</xml_diff>